<commit_message>
Canvia: read placeholder looks, stray markers and cell pictures as Android does
A placeholder now takes its words' look, anchor and insets from its layout's
and master's placeholders, and dates, footers and slide numbers use the
other style, so slide numbers no longer come in at 28 pt and title slides
keep their centred 60 pt titles. A deck's own *, _ or ~ that RichText would
read as a marker becomes a look-alike, so its characters and spans are kept.
A table cell's picture fill is counted as left out without storing a photo,
and the group depth limit is shared with the Android reader. The shared
deck gains a title slide that checks the placeholder looks.

Co-Authored-By: Claude Opus 5.5 <noreply@anthropic.com>
Claude-Session: https://claude.ai/code/session_01RZ82ffJX2CFvRa9HQ2fZmK
</commit_message>
<xml_diff>
--- a/Canvia/Tests/Fixtures/deck.pptx
+++ b/Canvia/Tests/Fixtures/deck.pptx
@@ -8,6 +8,7 @@
     <p:sldId id="256" r:id="rId3"/>
     <p:sldId id="257" r:id="rId2"/>
     <p:sldId id="258" r:id="rId4"/>
+    <p:sldId id="259" r:id="rId6"/>
   </p:sldIdLst>
   <p:sldSz cx="12192000" cy="6858000"/>
   <p:notesSz cx="6858000" cy="9144000"/>
@@ -112,6 +113,96 @@
           <a:lstStyle/>
           <a:p>
             <a:endParaRPr lang="en-GB"/>
+          </a:p>
+        </p:txBody>
+      </p:sp>
+    </p:spTree>
+  </p:cSld>
+  <p:clrMapOvr>
+    <a:masterClrMapping/>
+  </p:clrMapOvr>
+</p:sldLayout>
+</file>
+
+<file path=ppt/slideLayouts/slideLayout2.xml><?xml version="1.0" encoding="utf-8"?>
+<p:sldLayout xmlns:a="http://schemas.openxmlformats.org/drawingml/2006/main" xmlns:r="http://schemas.openxmlformats.org/officeDocument/2006/relationships" xmlns:p="http://schemas.openxmlformats.org/presentationml/2006/main" type="title" preserve="1">
+  <p:cSld name="Title Slide">
+    <p:spTree>
+      <p:nvGrpSpPr>
+        <p:cNvPr id="1" name=""/>
+        <p:cNvGrpSpPr/>
+        <p:nvPr/>
+      </p:nvGrpSpPr>
+      <p:grpSpPr/>
+      <p:sp>
+        <p:nvSpPr>
+          <p:cNvPr id="2" name="Title 1"/>
+          <p:cNvSpPr/>
+          <p:nvPr>
+            <p:ph type="ctrTitle"/>
+          </p:nvPr>
+        </p:nvSpPr>
+        <p:spPr>
+          <a:xfrm>
+            <a:off x="1524000" y="1122363"/>
+            <a:ext cx="9144000" cy="2387600"/>
+          </a:xfrm>
+        </p:spPr>
+        <p:txBody>
+          <a:bodyPr anchor="b"/>
+          <a:lstStyle>
+            <a:lvl1pPr algn="ctr">
+              <a:defRPr sz="6000"/>
+            </a:lvl1pPr>
+          </a:lstStyle>
+          <a:p>
+            <a:endParaRPr lang="en-GB"/>
+          </a:p>
+        </p:txBody>
+      </p:sp>
+      <p:sp>
+        <p:nvSpPr>
+          <p:cNvPr id="3" name="Subtitle 2"/>
+          <p:cNvSpPr/>
+          <p:nvPr>
+            <p:ph type="subTitle" idx="1"/>
+          </p:nvPr>
+        </p:nvSpPr>
+        <p:spPr>
+          <a:xfrm>
+            <a:off x="1524000" y="3602038"/>
+            <a:ext cx="9144000" cy="1655762"/>
+          </a:xfrm>
+        </p:spPr>
+        <p:txBody>
+          <a:bodyPr/>
+          <a:lstStyle>
+            <a:lvl1pPr marL="0" indent="0" algn="ctr">
+              <a:defRPr sz="2400"/>
+            </a:lvl1pPr>
+          </a:lstStyle>
+          <a:p>
+            <a:endParaRPr lang="en-GB"/>
+          </a:p>
+        </p:txBody>
+      </p:sp>
+      <p:sp>
+        <p:nvSpPr>
+          <p:cNvPr id="4" name="Slide Number Placeholder 3"/>
+          <p:cNvSpPr/>
+          <p:nvPr>
+            <p:ph type="sldNum" sz="quarter" idx="12"/>
+          </p:nvPr>
+        </p:nvSpPr>
+        <p:spPr/>
+        <p:txBody>
+          <a:bodyPr/>
+          <a:lstStyle/>
+          <a:p>
+            <a:fld id="{B6F15528-21DE-4FAA-801E-634DDDAF4B2B}" type="slidenum">
+              <a:rPr lang="en-GB"/>
+              <a:t>&lt;#&gt;</a:t>
+            </a:fld>
           </a:p>
         </p:txBody>
       </p:sp>
@@ -194,11 +285,48 @@
           </a:p>
         </p:txBody>
       </p:sp>
+      <p:sp>
+        <p:nvSpPr>
+          <p:cNvPr id="4" name="Slide Number Placeholder 3"/>
+          <p:cNvSpPr/>
+          <p:nvPr>
+            <p:ph type="sldNum" sz="quarter" idx="4"/>
+          </p:nvPr>
+        </p:nvSpPr>
+        <p:spPr>
+          <a:xfrm>
+            <a:off x="8610600" y="6356350"/>
+            <a:ext cx="2743200" cy="365125"/>
+          </a:xfrm>
+          <a:prstGeom prst="rect">
+            <a:avLst/>
+          </a:prstGeom>
+        </p:spPr>
+        <p:txBody>
+          <a:bodyPr anchor="ctr"/>
+          <a:lstStyle>
+            <a:lvl1pPr algn="r">
+              <a:defRPr sz="1200">
+                <a:solidFill>
+                  <a:srgbClr val="898989"/>
+                </a:solidFill>
+              </a:defRPr>
+            </a:lvl1pPr>
+          </a:lstStyle>
+          <a:p>
+            <a:fld id="{B6F15528-21DE-4FAA-801E-634DDDAF4B2B}" type="slidenum">
+              <a:rPr lang="en-GB"/>
+              <a:t>&lt;#&gt;</a:t>
+            </a:fld>
+          </a:p>
+        </p:txBody>
+      </p:sp>
     </p:spTree>
   </p:cSld>
   <p:clrMap bg1="lt1" tx1="dk1" bg2="lt2" tx2="dk2" accent1="accent1" accent2="accent2" accent3="accent3" accent4="accent4" accent5="accent5" accent6="accent6" hlink="hlink" folHlink="folHlink"/>
   <p:sldLayoutIdLst>
     <p:sldLayoutId id="2147483649" r:id="rId1"/>
+    <p:sldLayoutId id="2147483650" r:id="rId3"/>
   </p:sldLayoutIdLst>
   <p:txStyles>
     <p:titleStyle>
@@ -921,6 +1049,81 @@
 </p:sld>
 </file>
 
+<file path=ppt/slides/slide4.xml><?xml version="1.0" encoding="utf-8"?>
+<p:sld xmlns:a="http://schemas.openxmlformats.org/drawingml/2006/main" xmlns:r="http://schemas.openxmlformats.org/officeDocument/2006/relationships" xmlns:p="http://schemas.openxmlformats.org/presentationml/2006/main">
+  <p:cSld>
+    <p:spTree>
+      <p:nvGrpSpPr>
+        <p:cNvPr id="1" name=""/>
+        <p:cNvGrpSpPr/>
+        <p:nvPr/>
+      </p:nvGrpSpPr>
+      <p:grpSpPr/>
+      <p:sp>
+        <p:nvSpPr>
+          <p:cNvPr id="2" name="Title 1"/>
+          <p:cNvSpPr/>
+          <p:nvPr>
+            <p:ph type="ctrTitle"/>
+          </p:nvPr>
+        </p:nvSpPr>
+        <p:spPr/>
+        <p:txBody>
+          <a:bodyPr/>
+          <a:lstStyle/>
+          <a:p>
+            <a:r>
+              <a:rPr lang="en-GB"/>
+              <a:t>Launch day</a:t>
+            </a:r>
+          </a:p>
+        </p:txBody>
+      </p:sp>
+      <p:sp>
+        <p:nvSpPr>
+          <p:cNvPr id="3" name="Subtitle 2"/>
+          <p:cNvSpPr/>
+          <p:nvPr>
+            <p:ph type="subTitle" idx="1"/>
+          </p:nvPr>
+        </p:nvSpPr>
+        <p:spPr/>
+        <p:txBody>
+          <a:bodyPr/>
+          <a:lstStyle/>
+          <a:p>
+            <a:r>
+              <a:rPr lang="en-GB"/>
+              <a:t>Doors open at ten</a:t>
+            </a:r>
+          </a:p>
+        </p:txBody>
+      </p:sp>
+      <p:sp>
+        <p:nvSpPr>
+          <p:cNvPr id="4" name="Slide Number Placeholder 3"/>
+          <p:cNvSpPr/>
+          <p:nvPr>
+            <p:ph type="sldNum" sz="quarter" idx="12"/>
+          </p:nvPr>
+        </p:nvSpPr>
+        <p:spPr/>
+        <p:txBody>
+          <a:bodyPr/>
+          <a:lstStyle/>
+          <a:p>
+            <a:fld id="{B6F15528-21DE-4FAA-801E-634DDDAF4B2B}" type="slidenum">
+              <a:rPr lang="en-GB"/>
+              <a:t>4</a:t>
+            </a:fld>
+          </a:p>
+        </p:txBody>
+      </p:sp>
+    </p:spTree>
+  </p:cSld>
+</p:sld>
+</file>
+
 <file path=ppt/theme/theme1.xml><?xml version="1.0" encoding="utf-8"?>
 <a:theme xmlns:a="http://schemas.openxmlformats.org/drawingml/2006/main" name="Office">
   <a:themeElements>

</xml_diff>

<commit_message>
Canvia: PowerPoint text reads as on Android
A run's strikethrough and letter spacing now come from its list style's
defaults too, not only its own properties, as on Android. The shared
deck gains its text-fidelity slide (lists, numbering from 4, spacing,
strikethrough, links and a box shrunk to fit), asserted against the same
deck.json Android asserts, with the shared rows for unrounded spacing,
the longest run, a shape's own link and shrink-to-fit read from the
layout.

Co-Authored-By: Claude Opus 5.5 <noreply@anthropic.com>
Claude-Session: https://claude.ai/code/session_01RZ82ffJX2CFvRa9HQ2fZmK
</commit_message>
<xml_diff>
--- a/Canvia/Tests/Fixtures/deck.pptx
+++ b/Canvia/Tests/Fixtures/deck.pptx
@@ -9,6 +9,7 @@
     <p:sldId id="257" r:id="rId2"/>
     <p:sldId id="258" r:id="rId4"/>
     <p:sldId id="259" r:id="rId6"/>
+    <p:sldId id="260" r:id="rId7"/>
   </p:sldIdLst>
   <p:sldSz cx="12192000" cy="6858000"/>
   <p:notesSz cx="6858000" cy="9144000"/>
@@ -1124,6 +1125,231 @@
 </p:sld>
 </file>
 
+<file path=ppt/slides/slide5.xml><?xml version="1.0" encoding="utf-8"?>
+<p:sld xmlns:a="http://schemas.openxmlformats.org/drawingml/2006/main" xmlns:r="http://schemas.openxmlformats.org/officeDocument/2006/relationships" xmlns:p="http://schemas.openxmlformats.org/presentationml/2006/main">
+  <p:cSld>
+    <p:spTree>
+      <p:nvGrpSpPr>
+        <p:cNvPr id="1" name=""/>
+        <p:cNvGrpSpPr/>
+        <p:nvPr/>
+      </p:nvGrpSpPr>
+      <p:grpSpPr/>
+      <p:sp>
+        <p:nvSpPr>
+          <p:cNvPr id="2" name="TextBox 1"/>
+          <p:cNvSpPr txBox="1"/>
+          <p:nvPr/>
+        </p:nvSpPr>
+        <p:spPr>
+          <a:xfrm>
+            <a:off x="952500" y="952500"/>
+            <a:ext cx="4762500" cy="2857500"/>
+          </a:xfrm>
+          <a:prstGeom prst="rect">
+            <a:avLst/>
+          </a:prstGeom>
+          <a:noFill/>
+        </p:spPr>
+        <p:txBody>
+          <a:bodyPr lIns="0" tIns="0" rIns="0" bIns="0"/>
+          <a:lstStyle>
+            <a:lvl2pPr marL="742950" indent="-285750">
+              <a:buFont typeface="Arial"/>
+              <a:buChar char="–"/>
+            </a:lvl2pPr>
+            <a:lvl3pPr marL="1143000" indent="-228600">
+              <a:buFont typeface="Arial"/>
+              <a:buChar char="▪"/>
+            </a:lvl3pPr>
+          </a:lstStyle>
+          <a:p>
+            <a:pPr marL="342900" indent="-342900">
+              <a:buFont typeface="Arial"/>
+              <a:buChar char="•"/>
+            </a:pPr>
+            <a:r>
+              <a:rPr lang="en-GB" sz="2400">
+                <a:latin typeface="Lora"/>
+              </a:rPr>
+              <a:t>Plan</a:t>
+            </a:r>
+          </a:p>
+          <a:p>
+            <a:pPr lvl="1"/>
+            <a:r>
+              <a:rPr lang="en-GB" sz="2400">
+                <a:latin typeface="Lora"/>
+              </a:rPr>
+              <a:t>Draft</a:t>
+            </a:r>
+          </a:p>
+          <a:p>
+            <a:pPr lvl="2"/>
+            <a:r>
+              <a:rPr lang="en-GB" sz="2400">
+                <a:latin typeface="Lora"/>
+              </a:rPr>
+              <a:t>Review</a:t>
+            </a:r>
+          </a:p>
+          <a:p>
+            <a:pPr marL="342900" indent="-342900">
+              <a:buAutoNum type="arabicPeriod" startAt="4"/>
+            </a:pPr>
+            <a:r>
+              <a:rPr lang="en-GB" sz="2400">
+                <a:latin typeface="Lora"/>
+              </a:rPr>
+              <a:t>Fourth</a:t>
+            </a:r>
+          </a:p>
+          <a:p>
+            <a:pPr marL="342900" indent="-342900">
+              <a:buAutoNum type="arabicPeriod" startAt="4"/>
+            </a:pPr>
+            <a:r>
+              <a:rPr lang="en-GB" sz="2400">
+                <a:latin typeface="Lora"/>
+              </a:rPr>
+              <a:t>Fifth</a:t>
+            </a:r>
+          </a:p>
+          <a:p>
+            <a:pPr>
+              <a:buNone/>
+            </a:pPr>
+            <a:r>
+              <a:rPr lang="en-GB" sz="2400">
+                <a:latin typeface="Lora"/>
+              </a:rPr>
+              <a:t>Done</a:t>
+            </a:r>
+          </a:p>
+        </p:txBody>
+      </p:sp>
+      <p:sp>
+        <p:nvSpPr>
+          <p:cNvPr id="3" name="TextBox 2"/>
+          <p:cNvSpPr txBox="1"/>
+          <p:nvPr/>
+        </p:nvSpPr>
+        <p:spPr>
+          <a:xfrm>
+            <a:off x="6096000" y="952500"/>
+            <a:ext cx="4762500" cy="1905000"/>
+          </a:xfrm>
+          <a:prstGeom prst="rect">
+            <a:avLst/>
+          </a:prstGeom>
+          <a:noFill/>
+        </p:spPr>
+        <p:txBody>
+          <a:bodyPr lIns="0" tIns="0" rIns="0" bIns="0"/>
+          <a:lstStyle/>
+          <a:p>
+            <a:pPr algn="l">
+              <a:lnSpc>
+                <a:spcPct val="150000"/>
+              </a:lnSpc>
+              <a:spcAft>
+                <a:spcPts val="1200"/>
+              </a:spcAft>
+            </a:pPr>
+            <a:r>
+              <a:rPr lang="en-GB" sz="2400" spc="300">
+                <a:latin typeface="Lora"/>
+              </a:rPr>
+              <a:t>Read the </a:t>
+            </a:r>
+            <a:r>
+              <a:rPr lang="en-GB" sz="2400" spc="300" strike="sngStrike">
+                <a:latin typeface="Lora"/>
+              </a:rPr>
+              <a:t>old</a:t>
+            </a:r>
+            <a:r>
+              <a:rPr lang="en-GB" sz="2400" spc="300">
+                <a:latin typeface="Lora"/>
+              </a:rPr>
+              <a:t> news first</a:t>
+            </a:r>
+          </a:p>
+          <a:p>
+            <a:pPr algn="l">
+              <a:lnSpc>
+                <a:spcPct val="150000"/>
+              </a:lnSpc>
+              <a:spcAft>
+                <a:spcPts val="1200"/>
+              </a:spcAft>
+            </a:pPr>
+            <a:r>
+              <a:rPr lang="en-GB" sz="2400" spc="300">
+                <a:latin typeface="Lora"/>
+              </a:rPr>
+              <a:t>Visit </a:t>
+            </a:r>
+            <a:r>
+              <a:rPr lang="en-GB" sz="2400" spc="300">
+                <a:latin typeface="Lora"/>
+                <a:hlinkClick r:id="rId2"/>
+              </a:rPr>
+              <a:t>our site</a:t>
+            </a:r>
+            <a:r>
+              <a:rPr lang="en-GB" sz="2400" spc="300">
+                <a:latin typeface="Lora"/>
+              </a:rPr>
+              <a:t> or </a:t>
+            </a:r>
+            <a:r>
+              <a:rPr lang="en-GB" sz="2400" spc="300">
+                <a:latin typeface="Lora"/>
+                <a:hlinkClick r:id="rId3" action="ppaction://hlinksldjump"/>
+              </a:rPr>
+              <a:t>slide one</a:t>
+            </a:r>
+          </a:p>
+        </p:txBody>
+      </p:sp>
+      <p:sp>
+        <p:nvSpPr>
+          <p:cNvPr id="4" name="TextBox 3"/>
+          <p:cNvSpPr txBox="1"/>
+          <p:nvPr/>
+        </p:nvSpPr>
+        <p:spPr>
+          <a:xfrm>
+            <a:off x="6096000" y="3810000"/>
+            <a:ext cx="4762500" cy="952500"/>
+          </a:xfrm>
+          <a:prstGeom prst="rect">
+            <a:avLst/>
+          </a:prstGeom>
+          <a:noFill/>
+        </p:spPr>
+        <p:txBody>
+          <a:bodyPr lIns="0" tIns="0" rIns="0" bIns="0">
+            <a:normAutofit fontScale="62500" lnSpcReduction="20000"/>
+          </a:bodyPr>
+          <a:lstStyle/>
+          <a:p>
+            <a:pPr algn="l"/>
+            <a:r>
+              <a:rPr lang="en-GB" sz="4800">
+                <a:latin typeface="Lora"/>
+              </a:rPr>
+              <a:t>Shrunk to fit</a:t>
+            </a:r>
+          </a:p>
+        </p:txBody>
+      </p:sp>
+    </p:spTree>
+  </p:cSld>
+</p:sld>
+</file>
+
 <file path=ppt/theme/theme1.xml><?xml version="1.0" encoding="utf-8"?>
 <a:theme xmlns:a="http://schemas.openxmlformats.org/drawingml/2006/main" name="Office">
   <a:themeElements>

</xml_diff>